<commit_message>
Complete revamp in Fall 2026
</commit_message>
<xml_diff>
--- a/PPT/GameDesignLecture-Brainstorming-and-GroupDynamics.pptx
+++ b/PPT/GameDesignLecture-Brainstorming-and-GroupDynamics.pptx
@@ -236,7 +236,7 @@
           <a:p>
             <a:fld id="{590054AD-ED95-4521-A038-9193CEC69CBB}" type="datetimeFigureOut">
               <a:rPr lang="en-US" smtClean="0"/>
-              <a:t>7/11/2021</a:t>
+              <a:t>10/6/2026</a:t>
             </a:fld>
             <a:endParaRPr lang="en-US"/>
           </a:p>
@@ -1123,7 +1123,7 @@
           <a:p>
             <a:fld id="{48A87A34-81AB-432B-8DAE-1953F412C126}" type="datetimeFigureOut">
               <a:rPr lang="en-US" dirty="0"/>
-              <a:t>7/11/2021</a:t>
+              <a:t>10/6/2026</a:t>
             </a:fld>
             <a:endParaRPr lang="en-US" dirty="0"/>
           </a:p>
@@ -1385,7 +1385,7 @@
           <a:p>
             <a:fld id="{48A87A34-81AB-432B-8DAE-1953F412C126}" type="datetimeFigureOut">
               <a:rPr lang="en-US" dirty="0"/>
-              <a:t>7/11/2021</a:t>
+              <a:t>10/6/2026</a:t>
             </a:fld>
             <a:endParaRPr lang="en-US" dirty="0"/>
           </a:p>
@@ -1612,7 +1612,7 @@
             <a:fld id="{48A87A34-81AB-432B-8DAE-1953F412C126}" type="datetimeFigureOut">
               <a:rPr lang="en-US" dirty="0"/>
               <a:pPr/>
-              <a:t>7/11/2021</a:t>
+              <a:t>10/6/2026</a:t>
             </a:fld>
             <a:endParaRPr lang="en-US" dirty="0"/>
           </a:p>
@@ -1918,7 +1918,7 @@
             <a:fld id="{48A87A34-81AB-432B-8DAE-1953F412C126}" type="datetimeFigureOut">
               <a:rPr lang="en-US" dirty="0"/>
               <a:pPr/>
-              <a:t>7/11/2021</a:t>
+              <a:t>10/6/2026</a:t>
             </a:fld>
             <a:endParaRPr lang="en-US" dirty="0"/>
           </a:p>
@@ -2387,7 +2387,7 @@
             <a:fld id="{48A87A34-81AB-432B-8DAE-1953F412C126}" type="datetimeFigureOut">
               <a:rPr lang="en-US" dirty="0"/>
               <a:pPr/>
-              <a:t>7/11/2021</a:t>
+              <a:t>10/6/2026</a:t>
             </a:fld>
             <a:endParaRPr lang="en-US" dirty="0"/>
           </a:p>
@@ -2929,7 +2929,7 @@
           <a:p>
             <a:fld id="{48A87A34-81AB-432B-8DAE-1953F412C126}" type="datetimeFigureOut">
               <a:rPr lang="en-US" dirty="0"/>
-              <a:t>7/11/2021</a:t>
+              <a:t>10/6/2026</a:t>
             </a:fld>
             <a:endParaRPr lang="en-US" dirty="0"/>
           </a:p>
@@ -3698,7 +3698,7 @@
           <a:p>
             <a:fld id="{48A87A34-81AB-432B-8DAE-1953F412C126}" type="datetimeFigureOut">
               <a:rPr lang="en-US" dirty="0"/>
-              <a:t>7/11/2021</a:t>
+              <a:t>10/6/2026</a:t>
             </a:fld>
             <a:endParaRPr lang="en-US" dirty="0"/>
           </a:p>
@@ -3868,7 +3868,7 @@
           <a:p>
             <a:fld id="{48A87A34-81AB-432B-8DAE-1953F412C126}" type="datetimeFigureOut">
               <a:rPr lang="en-US" dirty="0"/>
-              <a:t>7/11/2021</a:t>
+              <a:t>10/6/2026</a:t>
             </a:fld>
             <a:endParaRPr lang="en-US" dirty="0"/>
           </a:p>
@@ -4087,7 +4087,7 @@
             <a:fld id="{48A87A34-81AB-432B-8DAE-1953F412C126}" type="datetimeFigureOut">
               <a:rPr lang="en-US" dirty="0"/>
               <a:pPr/>
-              <a:t>7/11/2021</a:t>
+              <a:t>10/6/2026</a:t>
             </a:fld>
             <a:endParaRPr lang="en-US" dirty="0"/>
           </a:p>
@@ -4262,7 +4262,7 @@
           <a:p>
             <a:fld id="{48A87A34-81AB-432B-8DAE-1953F412C126}" type="datetimeFigureOut">
               <a:rPr lang="en-US" dirty="0"/>
-              <a:t>7/11/2021</a:t>
+              <a:t>10/6/2026</a:t>
             </a:fld>
             <a:endParaRPr lang="en-US" dirty="0"/>
           </a:p>
@@ -4547,7 +4547,7 @@
             <a:fld id="{48A87A34-81AB-432B-8DAE-1953F412C126}" type="datetimeFigureOut">
               <a:rPr lang="en-US" dirty="0"/>
               <a:pPr/>
-              <a:t>7/11/2021</a:t>
+              <a:t>10/6/2026</a:t>
             </a:fld>
             <a:endParaRPr lang="en-US" dirty="0"/>
           </a:p>
@@ -4784,7 +4784,7 @@
           <a:p>
             <a:fld id="{48A87A34-81AB-432B-8DAE-1953F412C126}" type="datetimeFigureOut">
               <a:rPr lang="en-US" dirty="0"/>
-              <a:t>7/11/2021</a:t>
+              <a:t>10/6/2026</a:t>
             </a:fld>
             <a:endParaRPr lang="en-US" dirty="0"/>
           </a:p>
@@ -5158,7 +5158,7 @@
           <a:p>
             <a:fld id="{48A87A34-81AB-432B-8DAE-1953F412C126}" type="datetimeFigureOut">
               <a:rPr lang="en-US" dirty="0"/>
-              <a:t>7/11/2021</a:t>
+              <a:t>10/6/2026</a:t>
             </a:fld>
             <a:endParaRPr lang="en-US" dirty="0"/>
           </a:p>
@@ -5271,7 +5271,7 @@
           <a:p>
             <a:fld id="{48A87A34-81AB-432B-8DAE-1953F412C126}" type="datetimeFigureOut">
               <a:rPr lang="en-US" dirty="0"/>
-              <a:t>7/11/2021</a:t>
+              <a:t>10/6/2026</a:t>
             </a:fld>
             <a:endParaRPr lang="en-US" dirty="0"/>
           </a:p>
@@ -5361,7 +5361,7 @@
           <a:p>
             <a:fld id="{48A87A34-81AB-432B-8DAE-1953F412C126}" type="datetimeFigureOut">
               <a:rPr lang="en-US" dirty="0"/>
-              <a:t>7/11/2021</a:t>
+              <a:t>10/6/2026</a:t>
             </a:fld>
             <a:endParaRPr lang="en-US" dirty="0"/>
           </a:p>
@@ -5605,7 +5605,7 @@
           <a:p>
             <a:fld id="{48A87A34-81AB-432B-8DAE-1953F412C126}" type="datetimeFigureOut">
               <a:rPr lang="en-US" dirty="0"/>
-              <a:t>7/11/2021</a:t>
+              <a:t>10/6/2026</a:t>
             </a:fld>
             <a:endParaRPr lang="en-US" dirty="0"/>
           </a:p>
@@ -5857,7 +5857,7 @@
           <a:p>
             <a:fld id="{48A87A34-81AB-432B-8DAE-1953F412C126}" type="datetimeFigureOut">
               <a:rPr lang="en-US" dirty="0"/>
-              <a:t>7/11/2021</a:t>
+              <a:t>10/6/2026</a:t>
             </a:fld>
             <a:endParaRPr lang="en-US" dirty="0"/>
           </a:p>
@@ -6096,7 +6096,7 @@
             <a:fld id="{48A87A34-81AB-432B-8DAE-1953F412C126}" type="datetimeFigureOut">
               <a:rPr lang="en-US" dirty="0"/>
               <a:pPr/>
-              <a:t>7/11/2021</a:t>
+              <a:t>10/6/2026</a:t>
             </a:fld>
             <a:endParaRPr lang="en-US" dirty="0"/>
           </a:p>
@@ -19945,7 +19945,7 @@
         </p:spPr>
         <p:txBody>
           <a:bodyPr>
-            <a:normAutofit fontScale="47500" lnSpcReduction="20000"/>
+            <a:normAutofit fontScale="55000" lnSpcReduction="20000"/>
           </a:bodyPr>
           <a:lstStyle/>
           <a:p>
@@ -20117,22 +20117,12 @@
             </a:r>
             <a:r>
               <a:rPr lang="en-US" sz="2700" dirty="0"/>
-              <a:t> - Information about PTSD for game developers</a:t>
-            </a:r>
-          </a:p>
-          <a:p>
-            <a:r>
-              <a:rPr lang="en-US" sz="2700" dirty="0">
-                <a:hlinkClick r:id="rId11"/>
-              </a:rPr>
-              <a:t>https://docs.google.com/document/d/1HjlGwE57xlmp9Hf4u-mHt5qeem6kpbWJQzUWd0feDhg/edit?usp=sharing</a:t>
-            </a:r>
-            <a:r>
-              <a:rPr lang="en-US" sz="2700" dirty="0"/>
-              <a:t> – Link to a list of references that can be useful for brainstorming and working in a group. Some of the resources are repeats and some are ones that were not used in this presentation, but still helpful information.</a:t>
-            </a:r>
-          </a:p>
-          <a:p>
+              <a:t> - Information about PTSD for </a:t>
+            </a:r>
+            <a:r>
+              <a:rPr lang="en-US" sz="2700"/>
+              <a:t>game developers</a:t>
+            </a:r>
             <a:endParaRPr lang="en-US" dirty="0"/>
           </a:p>
           <a:p>
@@ -21665,7 +21655,7 @@
       <p:graphicFrame>
         <p:nvGraphicFramePr>
           <p:cNvPr id="4" name="Content Placeholder 3">
-            <a:hlinkClick r:id="rId3" action="ppaction://hlinkfile"/>
+            <a:hlinkClick r:id="rId2" action="ppaction://hlinkfile"/>
             <a:extLst>
               <a:ext uri="{FF2B5EF4-FFF2-40B4-BE49-F238E27FC236}">
                 <a16:creationId xmlns:a16="http://schemas.microsoft.com/office/drawing/2014/main" id="{5EDAC080-5988-401D-B2BA-4B6C1B8421F2}"/>
@@ -21692,12 +21682,12 @@
           <a:graphicData uri="http://schemas.openxmlformats.org/presentationml/2006/ole">
             <mc:AlternateContent xmlns:mc="http://schemas.openxmlformats.org/markup-compatibility/2006">
               <mc:Choice xmlns:v="urn:schemas-microsoft-com:vml" Requires="v">
-                <p:oleObj spid="_x0000_s1042" name="Packager Shell Object" showAsIcon="1" r:id="rId4" imgW="1099080" imgH="493200" progId="Package">
+                <p:oleObj name="Packager Shell Object" showAsIcon="1" r:id="rId3" imgW="1099080" imgH="493200" progId="Package">
                   <p:embed/>
                 </p:oleObj>
               </mc:Choice>
               <mc:Fallback>
-                <p:oleObj name="Packager Shell Object" showAsIcon="1" r:id="rId4" imgW="1099080" imgH="493200" progId="Package">
+                <p:oleObj name="Packager Shell Object" showAsIcon="1" r:id="rId3" imgW="1099080" imgH="493200" progId="Package">
                   <p:embed/>
                   <p:pic>
                     <p:nvPicPr>
@@ -21706,7 +21696,7 @@
                       <p:nvPr/>
                     </p:nvPicPr>
                     <p:blipFill>
-                      <a:blip r:embed="rId5"/>
+                      <a:blip r:embed="rId4"/>
                       <a:stretch>
                         <a:fillRect/>
                       </a:stretch>

</xml_diff>